<commit_message>
Add spot-price forecast process slide (block diagram) to ITK deck
Insert a fifth slide before the closing contact slide: a four-stage
horizontal block-flow diagram of the ITK NEM price-forecasting pipeline
(Inputs -> Build the fleet / LRMC -> Dispatch LP -> Price forecasts), with a
callout that spot prices emerge as the dual/shadow prices of each region's
supply = demand balance (same mechanism as AEMO's NEMDE). Content distilled
from the ITK NEM Price Forecasting System technical overview.

Also harden _no_shadow(): strip the themed shape <p:style> effectRef so
LibreOffice renders flat fills with no preset drop shadow on bands, dividers,
markers, and the new diagram boxes.

Co-Authored-By: Claude Opus 4.8 (1M context) <noreply@anthropic.com>
Claude-Session: https://claude.ai/code/session_01XsjCbG1WXTtw4XYPNjQ7eu
</commit_message>
<xml_diff>
--- a/presentations/itk_overview/itk_overview.pptx
+++ b/presentations/itk_overview/itk_overview.pptx
@@ -10,6 +10,7 @@
     <p:sldId id="258" r:id="rId9"/>
     <p:sldId id="259" r:id="rId10"/>
     <p:sldId id="260" r:id="rId11"/>
+    <p:sldId id="261" r:id="rId12"/>
   </p:sldIdLst>
   <p:sldSz cx="12191695" cy="6858000" type="screen4x3"/>
   <p:notesSz cx="6858000" cy="9144000"/>
@@ -3122,20 +3123,6 @@
           </a:ln>
           <a:effectLst/>
         </p:spPr>
-        <p:style>
-          <a:lnRef idx="1">
-            <a:schemeClr val="accent1"/>
-          </a:lnRef>
-          <a:fillRef idx="3">
-            <a:schemeClr val="accent1"/>
-          </a:fillRef>
-          <a:effectRef idx="2">
-            <a:schemeClr val="accent1"/>
-          </a:effectRef>
-          <a:fontRef idx="minor">
-            <a:schemeClr val="lt1"/>
-          </a:fontRef>
-        </p:style>
         <p:txBody>
           <a:bodyPr rtlCol="0" anchor="ctr"/>
           <a:lstStyle/>
@@ -3202,20 +3189,6 @@
           </a:ln>
           <a:effectLst/>
         </p:spPr>
-        <p:style>
-          <a:lnRef idx="1">
-            <a:schemeClr val="accent1"/>
-          </a:lnRef>
-          <a:fillRef idx="3">
-            <a:schemeClr val="accent1"/>
-          </a:fillRef>
-          <a:effectRef idx="2">
-            <a:schemeClr val="accent1"/>
-          </a:effectRef>
-          <a:fontRef idx="minor">
-            <a:schemeClr val="lt1"/>
-          </a:fontRef>
-        </p:style>
         <p:txBody>
           <a:bodyPr rtlCol="0" anchor="ctr"/>
           <a:lstStyle/>
@@ -3284,20 +3257,6 @@
           </a:ln>
           <a:effectLst/>
         </p:spPr>
-        <p:style>
-          <a:lnRef idx="1">
-            <a:schemeClr val="accent1"/>
-          </a:lnRef>
-          <a:fillRef idx="3">
-            <a:schemeClr val="accent1"/>
-          </a:fillRef>
-          <a:effectRef idx="2">
-            <a:schemeClr val="accent1"/>
-          </a:effectRef>
-          <a:fontRef idx="minor">
-            <a:schemeClr val="lt1"/>
-          </a:fontRef>
-        </p:style>
         <p:txBody>
           <a:bodyPr rtlCol="0" anchor="ctr" wrap="none" tIns="0" bIns="0"/>
           <a:lstStyle/>
@@ -3340,20 +3299,6 @@
           </a:ln>
           <a:effectLst/>
         </p:spPr>
-        <p:style>
-          <a:lnRef idx="1">
-            <a:schemeClr val="accent1"/>
-          </a:lnRef>
-          <a:fillRef idx="3">
-            <a:schemeClr val="accent1"/>
-          </a:fillRef>
-          <a:effectRef idx="2">
-            <a:schemeClr val="accent1"/>
-          </a:effectRef>
-          <a:fontRef idx="minor">
-            <a:schemeClr val="lt1"/>
-          </a:fontRef>
-        </p:style>
         <p:txBody>
           <a:bodyPr rtlCol="0" anchor="ctr" wrap="none" tIns="0" bIns="0"/>
           <a:lstStyle/>
@@ -3396,20 +3341,6 @@
           </a:ln>
           <a:effectLst/>
         </p:spPr>
-        <p:style>
-          <a:lnRef idx="1">
-            <a:schemeClr val="accent1"/>
-          </a:lnRef>
-          <a:fillRef idx="3">
-            <a:schemeClr val="accent1"/>
-          </a:fillRef>
-          <a:effectRef idx="2">
-            <a:schemeClr val="accent1"/>
-          </a:effectRef>
-          <a:fontRef idx="minor">
-            <a:schemeClr val="lt1"/>
-          </a:fontRef>
-        </p:style>
         <p:txBody>
           <a:bodyPr rtlCol="0" anchor="ctr" wrap="none" tIns="0" bIns="0"/>
           <a:lstStyle/>
@@ -3486,20 +3417,6 @@
           </a:ln>
           <a:effectLst/>
         </p:spPr>
-        <p:style>
-          <a:lnRef idx="1">
-            <a:schemeClr val="accent1"/>
-          </a:lnRef>
-          <a:fillRef idx="3">
-            <a:schemeClr val="accent1"/>
-          </a:fillRef>
-          <a:effectRef idx="2">
-            <a:schemeClr val="accent1"/>
-          </a:effectRef>
-          <a:fontRef idx="minor">
-            <a:schemeClr val="lt1"/>
-          </a:fontRef>
-        </p:style>
         <p:txBody>
           <a:bodyPr rtlCol="0" anchor="ctr"/>
           <a:lstStyle/>
@@ -3628,20 +3545,6 @@
           </a:ln>
           <a:effectLst/>
         </p:spPr>
-        <p:style>
-          <a:lnRef idx="1">
-            <a:schemeClr val="accent1"/>
-          </a:lnRef>
-          <a:fillRef idx="3">
-            <a:schemeClr val="accent1"/>
-          </a:fillRef>
-          <a:effectRef idx="2">
-            <a:schemeClr val="accent1"/>
-          </a:effectRef>
-          <a:fontRef idx="minor">
-            <a:schemeClr val="lt1"/>
-          </a:fontRef>
-        </p:style>
         <p:txBody>
           <a:bodyPr rtlCol="0" anchor="ctr"/>
           <a:lstStyle/>
@@ -3744,20 +3647,6 @@
           </a:ln>
           <a:effectLst/>
         </p:spPr>
-        <p:style>
-          <a:lnRef idx="1">
-            <a:schemeClr val="accent1"/>
-          </a:lnRef>
-          <a:fillRef idx="3">
-            <a:schemeClr val="accent1"/>
-          </a:fillRef>
-          <a:effectRef idx="2">
-            <a:schemeClr val="accent1"/>
-          </a:effectRef>
-          <a:fontRef idx="minor">
-            <a:schemeClr val="lt1"/>
-          </a:fontRef>
-        </p:style>
         <p:txBody>
           <a:bodyPr rtlCol="0" anchor="ctr"/>
           <a:lstStyle/>
@@ -3824,20 +3713,6 @@
           </a:ln>
           <a:effectLst/>
         </p:spPr>
-        <p:style>
-          <a:lnRef idx="1">
-            <a:schemeClr val="accent1"/>
-          </a:lnRef>
-          <a:fillRef idx="3">
-            <a:schemeClr val="accent1"/>
-          </a:fillRef>
-          <a:effectRef idx="2">
-            <a:schemeClr val="accent1"/>
-          </a:effectRef>
-          <a:fontRef idx="minor">
-            <a:schemeClr val="lt1"/>
-          </a:fontRef>
-        </p:style>
         <p:txBody>
           <a:bodyPr rtlCol="0" anchor="ctr"/>
           <a:lstStyle/>
@@ -3868,20 +3743,6 @@
           </a:ln>
           <a:effectLst/>
         </p:spPr>
-        <p:style>
-          <a:lnRef idx="1">
-            <a:schemeClr val="accent1"/>
-          </a:lnRef>
-          <a:fillRef idx="3">
-            <a:schemeClr val="accent1"/>
-          </a:fillRef>
-          <a:effectRef idx="2">
-            <a:schemeClr val="accent1"/>
-          </a:effectRef>
-          <a:fontRef idx="minor">
-            <a:schemeClr val="lt1"/>
-          </a:fontRef>
-        </p:style>
         <p:txBody>
           <a:bodyPr rtlCol="0" anchor="ctr"/>
           <a:lstStyle/>
@@ -3948,20 +3809,6 @@
           </a:ln>
           <a:effectLst/>
         </p:spPr>
-        <p:style>
-          <a:lnRef idx="1">
-            <a:schemeClr val="accent1"/>
-          </a:lnRef>
-          <a:fillRef idx="3">
-            <a:schemeClr val="accent1"/>
-          </a:fillRef>
-          <a:effectRef idx="2">
-            <a:schemeClr val="accent1"/>
-          </a:effectRef>
-          <a:fontRef idx="minor">
-            <a:schemeClr val="lt1"/>
-          </a:fontRef>
-        </p:style>
         <p:txBody>
           <a:bodyPr rtlCol="0" anchor="ctr"/>
           <a:lstStyle/>
@@ -3992,20 +3839,6 @@
           </a:ln>
           <a:effectLst/>
         </p:spPr>
-        <p:style>
-          <a:lnRef idx="1">
-            <a:schemeClr val="accent1"/>
-          </a:lnRef>
-          <a:fillRef idx="3">
-            <a:schemeClr val="accent1"/>
-          </a:fillRef>
-          <a:effectRef idx="2">
-            <a:schemeClr val="accent1"/>
-          </a:effectRef>
-          <a:fontRef idx="minor">
-            <a:schemeClr val="lt1"/>
-          </a:fontRef>
-        </p:style>
         <p:txBody>
           <a:bodyPr rtlCol="0" anchor="ctr"/>
           <a:lstStyle/>
@@ -4072,20 +3905,6 @@
           </a:ln>
           <a:effectLst/>
         </p:spPr>
-        <p:style>
-          <a:lnRef idx="1">
-            <a:schemeClr val="accent1"/>
-          </a:lnRef>
-          <a:fillRef idx="3">
-            <a:schemeClr val="accent1"/>
-          </a:fillRef>
-          <a:effectRef idx="2">
-            <a:schemeClr val="accent1"/>
-          </a:effectRef>
-          <a:fontRef idx="minor">
-            <a:schemeClr val="lt1"/>
-          </a:fontRef>
-        </p:style>
         <p:txBody>
           <a:bodyPr rtlCol="0" anchor="ctr"/>
           <a:lstStyle/>
@@ -4116,20 +3935,6 @@
           </a:ln>
           <a:effectLst/>
         </p:spPr>
-        <p:style>
-          <a:lnRef idx="1">
-            <a:schemeClr val="accent1"/>
-          </a:lnRef>
-          <a:fillRef idx="3">
-            <a:schemeClr val="accent1"/>
-          </a:fillRef>
-          <a:effectRef idx="2">
-            <a:schemeClr val="accent1"/>
-          </a:effectRef>
-          <a:fontRef idx="minor">
-            <a:schemeClr val="lt1"/>
-          </a:fontRef>
-        </p:style>
         <p:txBody>
           <a:bodyPr rtlCol="0" anchor="ctr"/>
           <a:lstStyle/>
@@ -4196,20 +4001,6 @@
           </a:ln>
           <a:effectLst/>
         </p:spPr>
-        <p:style>
-          <a:lnRef idx="1">
-            <a:schemeClr val="accent1"/>
-          </a:lnRef>
-          <a:fillRef idx="3">
-            <a:schemeClr val="accent1"/>
-          </a:fillRef>
-          <a:effectRef idx="2">
-            <a:schemeClr val="accent1"/>
-          </a:effectRef>
-          <a:fontRef idx="minor">
-            <a:schemeClr val="lt1"/>
-          </a:fontRef>
-        </p:style>
         <p:txBody>
           <a:bodyPr rtlCol="0" anchor="ctr"/>
           <a:lstStyle/>
@@ -4240,20 +4031,6 @@
           </a:ln>
           <a:effectLst/>
         </p:spPr>
-        <p:style>
-          <a:lnRef idx="1">
-            <a:schemeClr val="accent1"/>
-          </a:lnRef>
-          <a:fillRef idx="3">
-            <a:schemeClr val="accent1"/>
-          </a:fillRef>
-          <a:effectRef idx="2">
-            <a:schemeClr val="accent1"/>
-          </a:effectRef>
-          <a:fontRef idx="minor">
-            <a:schemeClr val="lt1"/>
-          </a:fontRef>
-        </p:style>
         <p:txBody>
           <a:bodyPr rtlCol="0" anchor="ctr"/>
           <a:lstStyle/>
@@ -4320,20 +4097,6 @@
           </a:ln>
           <a:effectLst/>
         </p:spPr>
-        <p:style>
-          <a:lnRef idx="1">
-            <a:schemeClr val="accent1"/>
-          </a:lnRef>
-          <a:fillRef idx="3">
-            <a:schemeClr val="accent1"/>
-          </a:fillRef>
-          <a:effectRef idx="2">
-            <a:schemeClr val="accent1"/>
-          </a:effectRef>
-          <a:fontRef idx="minor">
-            <a:schemeClr val="lt1"/>
-          </a:fontRef>
-        </p:style>
         <p:txBody>
           <a:bodyPr rtlCol="0" anchor="ctr"/>
           <a:lstStyle/>
@@ -4462,20 +4225,6 @@
           </a:ln>
           <a:effectLst/>
         </p:spPr>
-        <p:style>
-          <a:lnRef idx="1">
-            <a:schemeClr val="accent1"/>
-          </a:lnRef>
-          <a:fillRef idx="3">
-            <a:schemeClr val="accent1"/>
-          </a:fillRef>
-          <a:effectRef idx="2">
-            <a:schemeClr val="accent1"/>
-          </a:effectRef>
-          <a:fontRef idx="minor">
-            <a:schemeClr val="lt1"/>
-          </a:fontRef>
-        </p:style>
         <p:txBody>
           <a:bodyPr rtlCol="0" anchor="ctr"/>
           <a:lstStyle/>
@@ -4578,20 +4327,6 @@
           </a:ln>
           <a:effectLst/>
         </p:spPr>
-        <p:style>
-          <a:lnRef idx="1">
-            <a:schemeClr val="accent1"/>
-          </a:lnRef>
-          <a:fillRef idx="3">
-            <a:schemeClr val="accent1"/>
-          </a:fillRef>
-          <a:effectRef idx="2">
-            <a:schemeClr val="accent1"/>
-          </a:effectRef>
-          <a:fontRef idx="minor">
-            <a:schemeClr val="lt1"/>
-          </a:fontRef>
-        </p:style>
         <p:txBody>
           <a:bodyPr rtlCol="0" anchor="ctr"/>
           <a:lstStyle/>
@@ -4658,20 +4393,6 @@
           </a:ln>
           <a:effectLst/>
         </p:spPr>
-        <p:style>
-          <a:lnRef idx="1">
-            <a:schemeClr val="accent1"/>
-          </a:lnRef>
-          <a:fillRef idx="3">
-            <a:schemeClr val="accent1"/>
-          </a:fillRef>
-          <a:effectRef idx="2">
-            <a:schemeClr val="accent1"/>
-          </a:effectRef>
-          <a:fontRef idx="minor">
-            <a:schemeClr val="lt1"/>
-          </a:fontRef>
-        </p:style>
         <p:txBody>
           <a:bodyPr rtlCol="0" anchor="ctr"/>
           <a:lstStyle/>
@@ -4702,20 +4423,6 @@
           </a:ln>
           <a:effectLst/>
         </p:spPr>
-        <p:style>
-          <a:lnRef idx="1">
-            <a:schemeClr val="accent1"/>
-          </a:lnRef>
-          <a:fillRef idx="3">
-            <a:schemeClr val="accent1"/>
-          </a:fillRef>
-          <a:effectRef idx="2">
-            <a:schemeClr val="accent1"/>
-          </a:effectRef>
-          <a:fontRef idx="minor">
-            <a:schemeClr val="lt1"/>
-          </a:fontRef>
-        </p:style>
         <p:txBody>
           <a:bodyPr rtlCol="0" anchor="ctr"/>
           <a:lstStyle/>
@@ -4782,20 +4489,6 @@
           </a:ln>
           <a:effectLst/>
         </p:spPr>
-        <p:style>
-          <a:lnRef idx="1">
-            <a:schemeClr val="accent1"/>
-          </a:lnRef>
-          <a:fillRef idx="3">
-            <a:schemeClr val="accent1"/>
-          </a:fillRef>
-          <a:effectRef idx="2">
-            <a:schemeClr val="accent1"/>
-          </a:effectRef>
-          <a:fontRef idx="minor">
-            <a:schemeClr val="lt1"/>
-          </a:fontRef>
-        </p:style>
         <p:txBody>
           <a:bodyPr rtlCol="0" anchor="ctr"/>
           <a:lstStyle/>
@@ -4826,20 +4519,6 @@
           </a:ln>
           <a:effectLst/>
         </p:spPr>
-        <p:style>
-          <a:lnRef idx="1">
-            <a:schemeClr val="accent1"/>
-          </a:lnRef>
-          <a:fillRef idx="3">
-            <a:schemeClr val="accent1"/>
-          </a:fillRef>
-          <a:effectRef idx="2">
-            <a:schemeClr val="accent1"/>
-          </a:effectRef>
-          <a:fontRef idx="minor">
-            <a:schemeClr val="lt1"/>
-          </a:fontRef>
-        </p:style>
         <p:txBody>
           <a:bodyPr rtlCol="0" anchor="ctr"/>
           <a:lstStyle/>
@@ -4906,20 +4585,6 @@
           </a:ln>
           <a:effectLst/>
         </p:spPr>
-        <p:style>
-          <a:lnRef idx="1">
-            <a:schemeClr val="accent1"/>
-          </a:lnRef>
-          <a:fillRef idx="3">
-            <a:schemeClr val="accent1"/>
-          </a:fillRef>
-          <a:effectRef idx="2">
-            <a:schemeClr val="accent1"/>
-          </a:effectRef>
-          <a:fontRef idx="minor">
-            <a:schemeClr val="lt1"/>
-          </a:fontRef>
-        </p:style>
         <p:txBody>
           <a:bodyPr rtlCol="0" anchor="ctr"/>
           <a:lstStyle/>
@@ -4950,20 +4615,6 @@
           </a:ln>
           <a:effectLst/>
         </p:spPr>
-        <p:style>
-          <a:lnRef idx="1">
-            <a:schemeClr val="accent1"/>
-          </a:lnRef>
-          <a:fillRef idx="3">
-            <a:schemeClr val="accent1"/>
-          </a:fillRef>
-          <a:effectRef idx="2">
-            <a:schemeClr val="accent1"/>
-          </a:effectRef>
-          <a:fontRef idx="minor">
-            <a:schemeClr val="lt1"/>
-          </a:fontRef>
-        </p:style>
         <p:txBody>
           <a:bodyPr rtlCol="0" anchor="ctr"/>
           <a:lstStyle/>
@@ -5030,20 +4681,6 @@
           </a:ln>
           <a:effectLst/>
         </p:spPr>
-        <p:style>
-          <a:lnRef idx="1">
-            <a:schemeClr val="accent1"/>
-          </a:lnRef>
-          <a:fillRef idx="3">
-            <a:schemeClr val="accent1"/>
-          </a:fillRef>
-          <a:effectRef idx="2">
-            <a:schemeClr val="accent1"/>
-          </a:effectRef>
-          <a:fontRef idx="minor">
-            <a:schemeClr val="lt1"/>
-          </a:fontRef>
-        </p:style>
         <p:txBody>
           <a:bodyPr rtlCol="0" anchor="ctr"/>
           <a:lstStyle/>
@@ -5074,20 +4711,6 @@
           </a:ln>
           <a:effectLst/>
         </p:spPr>
-        <p:style>
-          <a:lnRef idx="1">
-            <a:schemeClr val="accent1"/>
-          </a:lnRef>
-          <a:fillRef idx="3">
-            <a:schemeClr val="accent1"/>
-          </a:fillRef>
-          <a:effectRef idx="2">
-            <a:schemeClr val="accent1"/>
-          </a:effectRef>
-          <a:fontRef idx="minor">
-            <a:schemeClr val="lt1"/>
-          </a:fontRef>
-        </p:style>
         <p:txBody>
           <a:bodyPr rtlCol="0" anchor="ctr"/>
           <a:lstStyle/>
@@ -5154,20 +4777,6 @@
           </a:ln>
           <a:effectLst/>
         </p:spPr>
-        <p:style>
-          <a:lnRef idx="1">
-            <a:schemeClr val="accent1"/>
-          </a:lnRef>
-          <a:fillRef idx="3">
-            <a:schemeClr val="accent1"/>
-          </a:fillRef>
-          <a:effectRef idx="2">
-            <a:schemeClr val="accent1"/>
-          </a:effectRef>
-          <a:fontRef idx="minor">
-            <a:schemeClr val="lt1"/>
-          </a:fontRef>
-        </p:style>
         <p:txBody>
           <a:bodyPr rtlCol="0" anchor="ctr"/>
           <a:lstStyle/>
@@ -5296,20 +4905,6 @@
           </a:ln>
           <a:effectLst/>
         </p:spPr>
-        <p:style>
-          <a:lnRef idx="1">
-            <a:schemeClr val="accent1"/>
-          </a:lnRef>
-          <a:fillRef idx="3">
-            <a:schemeClr val="accent1"/>
-          </a:fillRef>
-          <a:effectRef idx="2">
-            <a:schemeClr val="accent1"/>
-          </a:effectRef>
-          <a:fontRef idx="minor">
-            <a:schemeClr val="lt1"/>
-          </a:fontRef>
-        </p:style>
         <p:txBody>
           <a:bodyPr rtlCol="0" anchor="ctr"/>
           <a:lstStyle/>
@@ -5412,20 +5007,6 @@
           </a:ln>
           <a:effectLst/>
         </p:spPr>
-        <p:style>
-          <a:lnRef idx="1">
-            <a:schemeClr val="accent1"/>
-          </a:lnRef>
-          <a:fillRef idx="3">
-            <a:schemeClr val="accent1"/>
-          </a:fillRef>
-          <a:effectRef idx="2">
-            <a:schemeClr val="accent1"/>
-          </a:effectRef>
-          <a:fontRef idx="minor">
-            <a:schemeClr val="lt1"/>
-          </a:fontRef>
-        </p:style>
         <p:txBody>
           <a:bodyPr rtlCol="0" anchor="ctr"/>
           <a:lstStyle/>
@@ -5492,20 +5073,6 @@
           </a:ln>
           <a:effectLst/>
         </p:spPr>
-        <p:style>
-          <a:lnRef idx="1">
-            <a:schemeClr val="accent1"/>
-          </a:lnRef>
-          <a:fillRef idx="3">
-            <a:schemeClr val="accent1"/>
-          </a:fillRef>
-          <a:effectRef idx="2">
-            <a:schemeClr val="accent1"/>
-          </a:effectRef>
-          <a:fontRef idx="minor">
-            <a:schemeClr val="lt1"/>
-          </a:fontRef>
-        </p:style>
         <p:txBody>
           <a:bodyPr rtlCol="0" anchor="ctr"/>
           <a:lstStyle/>
@@ -5536,20 +5103,6 @@
           </a:ln>
           <a:effectLst/>
         </p:spPr>
-        <p:style>
-          <a:lnRef idx="1">
-            <a:schemeClr val="accent1"/>
-          </a:lnRef>
-          <a:fillRef idx="3">
-            <a:schemeClr val="accent1"/>
-          </a:fillRef>
-          <a:effectRef idx="2">
-            <a:schemeClr val="accent1"/>
-          </a:effectRef>
-          <a:fontRef idx="minor">
-            <a:schemeClr val="lt1"/>
-          </a:fontRef>
-        </p:style>
         <p:txBody>
           <a:bodyPr rtlCol="0" anchor="ctr"/>
           <a:lstStyle/>
@@ -5616,20 +5169,6 @@
           </a:ln>
           <a:effectLst/>
         </p:spPr>
-        <p:style>
-          <a:lnRef idx="1">
-            <a:schemeClr val="accent1"/>
-          </a:lnRef>
-          <a:fillRef idx="3">
-            <a:schemeClr val="accent1"/>
-          </a:fillRef>
-          <a:effectRef idx="2">
-            <a:schemeClr val="accent1"/>
-          </a:effectRef>
-          <a:fontRef idx="minor">
-            <a:schemeClr val="lt1"/>
-          </a:fontRef>
-        </p:style>
         <p:txBody>
           <a:bodyPr rtlCol="0" anchor="ctr"/>
           <a:lstStyle/>
@@ -5660,20 +5199,6 @@
           </a:ln>
           <a:effectLst/>
         </p:spPr>
-        <p:style>
-          <a:lnRef idx="1">
-            <a:schemeClr val="accent1"/>
-          </a:lnRef>
-          <a:fillRef idx="3">
-            <a:schemeClr val="accent1"/>
-          </a:fillRef>
-          <a:effectRef idx="2">
-            <a:schemeClr val="accent1"/>
-          </a:effectRef>
-          <a:fontRef idx="minor">
-            <a:schemeClr val="lt1"/>
-          </a:fontRef>
-        </p:style>
         <p:txBody>
           <a:bodyPr rtlCol="0" anchor="ctr"/>
           <a:lstStyle/>
@@ -5740,20 +5265,6 @@
           </a:ln>
           <a:effectLst/>
         </p:spPr>
-        <p:style>
-          <a:lnRef idx="1">
-            <a:schemeClr val="accent1"/>
-          </a:lnRef>
-          <a:fillRef idx="3">
-            <a:schemeClr val="accent1"/>
-          </a:fillRef>
-          <a:effectRef idx="2">
-            <a:schemeClr val="accent1"/>
-          </a:effectRef>
-          <a:fontRef idx="minor">
-            <a:schemeClr val="lt1"/>
-          </a:fontRef>
-        </p:style>
         <p:txBody>
           <a:bodyPr rtlCol="0" anchor="ctr"/>
           <a:lstStyle/>
@@ -5784,20 +5295,6 @@
           </a:ln>
           <a:effectLst/>
         </p:spPr>
-        <p:style>
-          <a:lnRef idx="1">
-            <a:schemeClr val="accent1"/>
-          </a:lnRef>
-          <a:fillRef idx="3">
-            <a:schemeClr val="accent1"/>
-          </a:fillRef>
-          <a:effectRef idx="2">
-            <a:schemeClr val="accent1"/>
-          </a:effectRef>
-          <a:fontRef idx="minor">
-            <a:schemeClr val="lt1"/>
-          </a:fontRef>
-        </p:style>
         <p:txBody>
           <a:bodyPr rtlCol="0" anchor="ctr"/>
           <a:lstStyle/>
@@ -5864,20 +5361,6 @@
           </a:ln>
           <a:effectLst/>
         </p:spPr>
-        <p:style>
-          <a:lnRef idx="1">
-            <a:schemeClr val="accent1"/>
-          </a:lnRef>
-          <a:fillRef idx="3">
-            <a:schemeClr val="accent1"/>
-          </a:fillRef>
-          <a:effectRef idx="2">
-            <a:schemeClr val="accent1"/>
-          </a:effectRef>
-          <a:fontRef idx="minor">
-            <a:schemeClr val="lt1"/>
-          </a:fontRef>
-        </p:style>
         <p:txBody>
           <a:bodyPr rtlCol="0" anchor="ctr"/>
           <a:lstStyle/>
@@ -5908,20 +5391,6 @@
           </a:ln>
           <a:effectLst/>
         </p:spPr>
-        <p:style>
-          <a:lnRef idx="1">
-            <a:schemeClr val="accent1"/>
-          </a:lnRef>
-          <a:fillRef idx="3">
-            <a:schemeClr val="accent1"/>
-          </a:fillRef>
-          <a:effectRef idx="2">
-            <a:schemeClr val="accent1"/>
-          </a:effectRef>
-          <a:fontRef idx="minor">
-            <a:schemeClr val="lt1"/>
-          </a:fontRef>
-        </p:style>
         <p:txBody>
           <a:bodyPr rtlCol="0" anchor="ctr"/>
           <a:lstStyle/>
@@ -5988,20 +5457,6 @@
           </a:ln>
           <a:effectLst/>
         </p:spPr>
-        <p:style>
-          <a:lnRef idx="1">
-            <a:schemeClr val="accent1"/>
-          </a:lnRef>
-          <a:fillRef idx="3">
-            <a:schemeClr val="accent1"/>
-          </a:fillRef>
-          <a:effectRef idx="2">
-            <a:schemeClr val="accent1"/>
-          </a:effectRef>
-          <a:fontRef idx="minor">
-            <a:schemeClr val="lt1"/>
-          </a:fontRef>
-        </p:style>
         <p:txBody>
           <a:bodyPr rtlCol="0" anchor="ctr"/>
           <a:lstStyle/>
@@ -6110,14 +5565,50 @@
       <p:grpSpPr/>
       <p:sp>
         <p:nvSpPr>
-          <p:cNvPr id="2" name="Rectangle 1"/>
+          <p:cNvPr id="2" name="TextBox 1"/>
+          <p:cNvSpPr txBox="1"/>
+          <p:nvPr/>
+        </p:nvSpPr>
+        <p:spPr>
+          <a:xfrm>
+            <a:off x="548640" y="384048"/>
+            <a:ext cx="10972800" cy="548640"/>
+          </a:xfrm>
+          <a:prstGeom prst="rect">
+            <a:avLst/>
+          </a:prstGeom>
+          <a:noFill/>
+        </p:spPr>
+        <p:txBody>
+          <a:bodyPr wrap="square" anchor="t" lIns="0" rIns="0" tIns="0" bIns="0">
+            <a:spAutoFit/>
+          </a:bodyPr>
+          <a:lstStyle/>
+          <a:p>
+            <a:pPr algn="l"/>
+            <a:r>
+              <a:rPr sz="3000" b="1" i="0" lang="en-AU">
+                <a:solidFill>
+                  <a:srgbClr val="100F0F"/>
+                </a:solidFill>
+                <a:latin typeface="IBM Plex Sans"/>
+                <a:cs typeface="IBM Plex Sans"/>
+              </a:rPr>
+              <a:t>How the spot-price forecast works</a:t>
+            </a:r>
+          </a:p>
+        </p:txBody>
+      </p:sp>
+      <p:sp>
+        <p:nvSpPr>
+          <p:cNvPr id="3" name="Rectangle 2"/>
           <p:cNvSpPr/>
           <p:nvPr/>
         </p:nvSpPr>
         <p:spPr>
           <a:xfrm>
-            <a:off x="0" y="0"/>
-            <a:ext cx="320040" cy="6858000"/>
+            <a:off x="566928" y="969264"/>
+            <a:ext cx="2377440" cy="50800"/>
           </a:xfrm>
           <a:prstGeom prst="rect">
             <a:avLst/>
@@ -6130,20 +5621,6 @@
           </a:ln>
           <a:effectLst/>
         </p:spPr>
-        <p:style>
-          <a:lnRef idx="1">
-            <a:schemeClr val="accent1"/>
-          </a:lnRef>
-          <a:fillRef idx="3">
-            <a:schemeClr val="accent1"/>
-          </a:fillRef>
-          <a:effectRef idx="2">
-            <a:schemeClr val="accent1"/>
-          </a:effectRef>
-          <a:fontRef idx="minor">
-            <a:schemeClr val="lt1"/>
-          </a:fontRef>
-        </p:style>
         <p:txBody>
           <a:bodyPr rtlCol="0" anchor="ctr"/>
           <a:lstStyle/>
@@ -6154,14 +5631,14 @@
       </p:sp>
       <p:sp>
         <p:nvSpPr>
-          <p:cNvPr id="3" name="TextBox 2"/>
+          <p:cNvPr id="4" name="TextBox 3"/>
           <p:cNvSpPr txBox="1"/>
           <p:nvPr/>
         </p:nvSpPr>
         <p:spPr>
           <a:xfrm>
-            <a:off x="822960" y="2103120"/>
-            <a:ext cx="10058400" cy="914400"/>
+            <a:off x="566928" y="1078992"/>
+            <a:ext cx="11064240" cy="365760"/>
           </a:xfrm>
           <a:prstGeom prst="rect">
             <a:avLst/>
@@ -6176,54 +5653,40 @@
           <a:p>
             <a:pPr algn="l"/>
             <a:r>
-              <a:rPr sz="5400" b="1" i="0" lang="en-AU">
-                <a:solidFill>
-                  <a:srgbClr val="100F0F"/>
+              <a:rPr sz="1300" b="0" i="1" lang="en-AU">
+                <a:solidFill>
+                  <a:srgbClr val="575653"/>
                 </a:solidFill>
                 <a:latin typeface="IBM Plex Sans"/>
                 <a:cs typeface="IBM Plex Sans"/>
               </a:rPr>
-              <a:t>Let's talk</a:t>
-            </a:r>
-          </a:p>
-        </p:txBody>
-      </p:sp>
-      <p:sp>
-        <p:nvSpPr>
-          <p:cNvPr id="4" name="Rectangle 3"/>
+              <a:t>A dispatch-interval LP model of the National Electricity Market  ·  all five regions  ·  2025–2050</a:t>
+            </a:r>
+          </a:p>
+        </p:txBody>
+      </p:sp>
+      <p:sp>
+        <p:nvSpPr>
+          <p:cNvPr id="5" name="Rectangle 4"/>
           <p:cNvSpPr/>
           <p:nvPr/>
         </p:nvSpPr>
         <p:spPr>
           <a:xfrm>
-            <a:off x="914400" y="3154680"/>
-            <a:ext cx="2194560" cy="50800"/>
-          </a:xfrm>
-          <a:prstGeom prst="rect">
-            <a:avLst/>
-          </a:prstGeom>
-          <a:solidFill>
-            <a:srgbClr val="24837B"/>
+            <a:off x="548640" y="1691640"/>
+            <a:ext cx="2487168" cy="502920"/>
+          </a:xfrm>
+          <a:prstGeom prst="rect">
+            <a:avLst/>
+          </a:prstGeom>
+          <a:solidFill>
+            <a:srgbClr val="205EA6"/>
           </a:solidFill>
           <a:ln>
             <a:noFill/>
           </a:ln>
           <a:effectLst/>
         </p:spPr>
-        <p:style>
-          <a:lnRef idx="1">
-            <a:schemeClr val="accent1"/>
-          </a:lnRef>
-          <a:fillRef idx="3">
-            <a:schemeClr val="accent1"/>
-          </a:fillRef>
-          <a:effectRef idx="2">
-            <a:schemeClr val="accent1"/>
-          </a:effectRef>
-          <a:fontRef idx="minor">
-            <a:schemeClr val="lt1"/>
-          </a:fontRef>
-        </p:style>
         <p:txBody>
           <a:bodyPr rtlCol="0" anchor="ctr"/>
           <a:lstStyle/>
@@ -6234,14 +5697,14 @@
       </p:sp>
       <p:sp>
         <p:nvSpPr>
-          <p:cNvPr id="5" name="TextBox 4"/>
+          <p:cNvPr id="6" name="TextBox 5"/>
           <p:cNvSpPr txBox="1"/>
           <p:nvPr/>
         </p:nvSpPr>
         <p:spPr>
           <a:xfrm>
-            <a:off x="914400" y="3520440"/>
-            <a:ext cx="9144000" cy="457200"/>
+            <a:off x="548640" y="1691640"/>
+            <a:ext cx="2487168" cy="502920"/>
           </a:xfrm>
           <a:prstGeom prst="rect">
             <a:avLst/>
@@ -6249,35 +5712,76 @@
           <a:noFill/>
         </p:spPr>
         <p:txBody>
-          <a:bodyPr wrap="square" anchor="t" lIns="0" rIns="0" tIns="0" bIns="0">
+          <a:bodyPr wrap="none" anchor="ctr" lIns="118872" tIns="0" bIns="0">
             <a:spAutoFit/>
           </a:bodyPr>
           <a:lstStyle/>
           <a:p>
-            <a:pPr algn="l"/>
-            <a:r>
-              <a:rPr sz="2200" b="1" i="0" lang="en-AU">
-                <a:solidFill>
-                  <a:srgbClr val="100F0F"/>
+            <a:r>
+              <a:rPr sz="1300" b="1" i="0" lang="en-AU">
+                <a:solidFill>
+                  <a:srgbClr val="FFFCF0"/>
+                </a:solidFill>
+                <a:latin typeface="IBM Plex Mono"/>
+                <a:cs typeface="IBM Plex Mono"/>
+              </a:rPr>
+              <a:t>1   </a:t>
+            </a:r>
+            <a:r>
+              <a:rPr sz="1400" b="1" i="0" lang="en-AU">
+                <a:solidFill>
+                  <a:srgbClr val="FFFCF0"/>
                 </a:solidFill>
                 <a:latin typeface="IBM Plex Sans"/>
                 <a:cs typeface="IBM Plex Sans"/>
               </a:rPr>
-              <a:t>David Leitch</a:t>
-            </a:r>
-          </a:p>
-        </p:txBody>
-      </p:sp>
-      <p:sp>
-        <p:nvSpPr>
-          <p:cNvPr id="6" name="TextBox 5"/>
+              <a:t>Inputs</a:t>
+            </a:r>
+          </a:p>
+        </p:txBody>
+      </p:sp>
+      <p:sp>
+        <p:nvSpPr>
+          <p:cNvPr id="7" name="Rectangle 6"/>
+          <p:cNvSpPr/>
+          <p:nvPr/>
+        </p:nvSpPr>
+        <p:spPr>
+          <a:xfrm>
+            <a:off x="548640" y="2194560"/>
+            <a:ext cx="2487168" cy="2514600"/>
+          </a:xfrm>
+          <a:prstGeom prst="rect">
+            <a:avLst/>
+          </a:prstGeom>
+          <a:solidFill>
+            <a:srgbClr val="FFFCF0"/>
+          </a:solidFill>
+          <a:ln w="15875">
+            <a:solidFill>
+              <a:srgbClr val="205EA6"/>
+            </a:solidFill>
+          </a:ln>
+          <a:effectLst/>
+        </p:spPr>
+        <p:txBody>
+          <a:bodyPr rtlCol="0" anchor="ctr"/>
+          <a:lstStyle/>
+          <a:p>
+            <a:pPr algn="ctr"/>
+          </a:p>
+        </p:txBody>
+      </p:sp>
+      <p:sp>
+        <p:nvSpPr>
+          <p:cNvPr id="8" name="TextBox 7"/>
           <p:cNvSpPr txBox="1"/>
           <p:nvPr/>
         </p:nvSpPr>
         <p:spPr>
           <a:xfrm>
-            <a:off x="914400" y="3995928"/>
-            <a:ext cx="9144000" cy="457200"/>
+            <a:off x="548640" y="2194560"/>
+            <a:ext cx="2487168" cy="2514600"/>
           </a:xfrm>
           <a:prstGeom prst="rect">
             <a:avLst/>
@@ -6285,97 +5789,1391 @@
           <a:noFill/>
         </p:spPr>
         <p:txBody>
-          <a:bodyPr wrap="square" anchor="t" lIns="0" rIns="0" tIns="0" bIns="0">
+          <a:bodyPr wrap="square" anchor="ctr" lIns="118872" tIns="73152">
             <a:spAutoFit/>
           </a:bodyPr>
           <a:lstStyle/>
           <a:p>
-            <a:pPr algn="l"/>
-            <a:r>
-              <a:rPr sz="1800" b="0" i="0" lang="en-AU">
-                <a:solidFill>
-                  <a:srgbClr val="575653"/>
+            <a:pPr>
+              <a:lnSpc>
+                <a:spcPct val="105000"/>
+              </a:lnSpc>
+              <a:spcAft>
+                <a:spcPts val="700"/>
+              </a:spcAft>
+            </a:pPr>
+            <a:r>
+              <a:rPr sz="1100" b="1" i="0" lang="en-AU">
+                <a:solidFill>
+                  <a:srgbClr val="205EA6"/>
                 </a:solidFill>
                 <a:latin typeface="IBM Plex Sans"/>
                 <a:cs typeface="IBM Plex Sans"/>
               </a:rPr>
-              <a:t>ITK Services</a:t>
-            </a:r>
-          </a:p>
-        </p:txBody>
-      </p:sp>
-      <p:sp>
-        <p:nvSpPr>
-          <p:cNvPr id="7" name="TextBox 6"/>
-          <p:cNvSpPr txBox="1"/>
-          <p:nvPr/>
-        </p:nvSpPr>
-        <p:spPr>
-          <a:xfrm>
-            <a:off x="914400" y="4471416"/>
-            <a:ext cx="9144000" cy="457200"/>
-          </a:xfrm>
-          <a:prstGeom prst="rect">
-            <a:avLst/>
-          </a:prstGeom>
-          <a:noFill/>
-        </p:spPr>
-        <p:txBody>
-          <a:bodyPr wrap="square" anchor="t" lIns="0" rIns="0" tIns="0" bIns="0">
-            <a:spAutoFit/>
-          </a:bodyPr>
-          <a:lstStyle/>
-          <a:p>
-            <a:pPr algn="l"/>
-            <a:r>
-              <a:rPr sz="1800" b="0" i="0" lang="en-AU">
-                <a:solidFill>
-                  <a:srgbClr val="24837B"/>
-                </a:solidFill>
-                <a:latin typeface="IBM Plex Mono"/>
-                <a:cs typeface="IBM Plex Mono"/>
-              </a:rPr>
-              <a:t>david.leitch@itkservices.com.au</a:t>
-            </a:r>
-          </a:p>
-        </p:txBody>
-      </p:sp>
-      <p:sp>
-        <p:nvSpPr>
-          <p:cNvPr id="8" name="Rectangle 7"/>
+              <a:t>▪ </a:t>
+            </a:r>
+            <a:r>
+              <a:rPr sz="1100" b="0" i="0" lang="en-AU">
+                <a:solidFill>
+                  <a:srgbClr val="100F0F"/>
+                </a:solidFill>
+                <a:latin typeface="IBM Plex Sans"/>
+                <a:cs typeface="IBM Plex Sans"/>
+              </a:rPr>
+              <a:t>Demand forecast (AEMO ISP)</a:t>
+            </a:r>
+          </a:p>
+          <a:p>
+            <a:pPr>
+              <a:lnSpc>
+                <a:spcPct val="105000"/>
+              </a:lnSpc>
+              <a:spcAft>
+                <a:spcPts val="700"/>
+              </a:spcAft>
+            </a:pPr>
+            <a:r>
+              <a:rPr sz="1100" b="1" i="0" lang="en-AU">
+                <a:solidFill>
+                  <a:srgbClr val="205EA6"/>
+                </a:solidFill>
+                <a:latin typeface="IBM Plex Sans"/>
+                <a:cs typeface="IBM Plex Sans"/>
+              </a:rPr>
+              <a:t>▪ </a:t>
+            </a:r>
+            <a:r>
+              <a:rPr sz="1100" b="0" i="0" lang="en-AU">
+                <a:solidFill>
+                  <a:srgbClr val="100F0F"/>
+                </a:solidFill>
+                <a:latin typeface="IBM Plex Sans"/>
+                <a:cs typeface="IBM Plex Sans"/>
+              </a:rPr>
+              <a:t>Existing fleet · fuel &amp; carbon prices</a:t>
+            </a:r>
+          </a:p>
+          <a:p>
+            <a:pPr>
+              <a:lnSpc>
+                <a:spcPct val="105000"/>
+              </a:lnSpc>
+              <a:spcAft>
+                <a:spcPts val="700"/>
+              </a:spcAft>
+            </a:pPr>
+            <a:r>
+              <a:rPr sz="1100" b="1" i="0" lang="en-AU">
+                <a:solidFill>
+                  <a:srgbClr val="205EA6"/>
+                </a:solidFill>
+                <a:latin typeface="IBM Plex Sans"/>
+                <a:cs typeface="IBM Plex Sans"/>
+              </a:rPr>
+              <a:t>▪ </a:t>
+            </a:r>
+            <a:r>
+              <a:rPr sz="1100" b="0" i="0" lang="en-AU">
+                <a:solidFill>
+                  <a:srgbClr val="100F0F"/>
+                </a:solidFill>
+                <a:latin typeface="IBM Plex Sans"/>
+                <a:cs typeface="IBM Plex Sans"/>
+              </a:rPr>
+              <a:t>Wind &amp; solar traces — 13 weather years</a:t>
+            </a:r>
+          </a:p>
+          <a:p>
+            <a:pPr>
+              <a:lnSpc>
+                <a:spcPct val="105000"/>
+              </a:lnSpc>
+              <a:spcAft>
+                <a:spcPts val="700"/>
+              </a:spcAft>
+            </a:pPr>
+            <a:r>
+              <a:rPr sz="1100" b="1" i="0" lang="en-AU">
+                <a:solidFill>
+                  <a:srgbClr val="205EA6"/>
+                </a:solidFill>
+                <a:latin typeface="IBM Plex Sans"/>
+                <a:cs typeface="IBM Plex Sans"/>
+              </a:rPr>
+              <a:t>▪ </a:t>
+            </a:r>
+            <a:r>
+              <a:rPr sz="1100" b="0" i="0" lang="en-AU">
+                <a:solidFill>
+                  <a:srgbClr val="100F0F"/>
+                </a:solidFill>
+                <a:latin typeface="IBM Plex Sans"/>
+                <a:cs typeface="IBM Plex Sans"/>
+              </a:rPr>
+              <a:t>New-build costs (GenCost)</a:t>
+            </a:r>
+          </a:p>
+        </p:txBody>
+      </p:sp>
+      <p:sp>
+        <p:nvSpPr>
+          <p:cNvPr id="9" name="Right Arrow 8"/>
           <p:cNvSpPr/>
           <p:nvPr/>
         </p:nvSpPr>
         <p:spPr>
           <a:xfrm>
-            <a:off x="0" y="6419088"/>
-            <a:ext cx="12191695" cy="25400"/>
-          </a:xfrm>
-          <a:prstGeom prst="rect">
-            <a:avLst/>
-          </a:prstGeom>
-          <a:solidFill>
-            <a:srgbClr val="24837B"/>
+            <a:off x="3081528" y="3017520"/>
+            <a:ext cx="292608" cy="365760"/>
+          </a:xfrm>
+          <a:prstGeom prst="rightArrow">
+            <a:avLst/>
+          </a:prstGeom>
+          <a:solidFill>
+            <a:srgbClr val="B7B5AC"/>
           </a:solidFill>
           <a:ln>
             <a:noFill/>
           </a:ln>
           <a:effectLst/>
         </p:spPr>
-        <p:style>
-          <a:lnRef idx="1">
-            <a:schemeClr val="accent1"/>
-          </a:lnRef>
-          <a:fillRef idx="3">
-            <a:schemeClr val="accent1"/>
-          </a:fillRef>
-          <a:effectRef idx="2">
-            <a:schemeClr val="accent1"/>
-          </a:effectRef>
-          <a:fontRef idx="minor">
-            <a:schemeClr val="lt1"/>
-          </a:fontRef>
-        </p:style>
+        <p:txBody>
+          <a:bodyPr rtlCol="0" anchor="ctr"/>
+          <a:lstStyle/>
+          <a:p>
+            <a:pPr algn="ctr"/>
+          </a:p>
+        </p:txBody>
+      </p:sp>
+      <p:sp>
+        <p:nvSpPr>
+          <p:cNvPr id="10" name="Rectangle 9"/>
+          <p:cNvSpPr/>
+          <p:nvPr/>
+        </p:nvSpPr>
+        <p:spPr>
+          <a:xfrm>
+            <a:off x="3419856" y="1691640"/>
+            <a:ext cx="2487168" cy="502920"/>
+          </a:xfrm>
+          <a:prstGeom prst="rect">
+            <a:avLst/>
+          </a:prstGeom>
+          <a:solidFill>
+            <a:srgbClr val="66800B"/>
+          </a:solidFill>
+          <a:ln>
+            <a:noFill/>
+          </a:ln>
+          <a:effectLst/>
+        </p:spPr>
+        <p:txBody>
+          <a:bodyPr rtlCol="0" anchor="ctr"/>
+          <a:lstStyle/>
+          <a:p>
+            <a:pPr algn="ctr"/>
+          </a:p>
+        </p:txBody>
+      </p:sp>
+      <p:sp>
+        <p:nvSpPr>
+          <p:cNvPr id="11" name="TextBox 10"/>
+          <p:cNvSpPr txBox="1"/>
+          <p:nvPr/>
+        </p:nvSpPr>
+        <p:spPr>
+          <a:xfrm>
+            <a:off x="3419856" y="1691640"/>
+            <a:ext cx="2487168" cy="502920"/>
+          </a:xfrm>
+          <a:prstGeom prst="rect">
+            <a:avLst/>
+          </a:prstGeom>
+          <a:noFill/>
+        </p:spPr>
+        <p:txBody>
+          <a:bodyPr wrap="none" anchor="ctr" lIns="118872" tIns="0" bIns="0">
+            <a:spAutoFit/>
+          </a:bodyPr>
+          <a:lstStyle/>
+          <a:p>
+            <a:r>
+              <a:rPr sz="1300" b="1" i="0" lang="en-AU">
+                <a:solidFill>
+                  <a:srgbClr val="FFFCF0"/>
+                </a:solidFill>
+                <a:latin typeface="IBM Plex Mono"/>
+                <a:cs typeface="IBM Plex Mono"/>
+              </a:rPr>
+              <a:t>2   </a:t>
+            </a:r>
+            <a:r>
+              <a:rPr sz="1400" b="1" i="0" lang="en-AU">
+                <a:solidFill>
+                  <a:srgbClr val="FFFCF0"/>
+                </a:solidFill>
+                <a:latin typeface="IBM Plex Sans"/>
+                <a:cs typeface="IBM Plex Sans"/>
+              </a:rPr>
+              <a:t>Build the fleet</a:t>
+            </a:r>
+          </a:p>
+        </p:txBody>
+      </p:sp>
+      <p:sp>
+        <p:nvSpPr>
+          <p:cNvPr id="12" name="Rectangle 11"/>
+          <p:cNvSpPr/>
+          <p:nvPr/>
+        </p:nvSpPr>
+        <p:spPr>
+          <a:xfrm>
+            <a:off x="3419856" y="2194560"/>
+            <a:ext cx="2487168" cy="2514600"/>
+          </a:xfrm>
+          <a:prstGeom prst="rect">
+            <a:avLst/>
+          </a:prstGeom>
+          <a:solidFill>
+            <a:srgbClr val="FFFCF0"/>
+          </a:solidFill>
+          <a:ln w="15875">
+            <a:solidFill>
+              <a:srgbClr val="66800B"/>
+            </a:solidFill>
+          </a:ln>
+          <a:effectLst/>
+        </p:spPr>
+        <p:txBody>
+          <a:bodyPr rtlCol="0" anchor="ctr"/>
+          <a:lstStyle/>
+          <a:p>
+            <a:pPr algn="ctr"/>
+          </a:p>
+        </p:txBody>
+      </p:sp>
+      <p:sp>
+        <p:nvSpPr>
+          <p:cNvPr id="13" name="TextBox 12"/>
+          <p:cNvSpPr txBox="1"/>
+          <p:nvPr/>
+        </p:nvSpPr>
+        <p:spPr>
+          <a:xfrm>
+            <a:off x="3419856" y="2194560"/>
+            <a:ext cx="2487168" cy="2514600"/>
+          </a:xfrm>
+          <a:prstGeom prst="rect">
+            <a:avLst/>
+          </a:prstGeom>
+          <a:noFill/>
+        </p:spPr>
+        <p:txBody>
+          <a:bodyPr wrap="square" anchor="ctr" lIns="118872" tIns="73152">
+            <a:spAutoFit/>
+          </a:bodyPr>
+          <a:lstStyle/>
+          <a:p>
+            <a:pPr>
+              <a:lnSpc>
+                <a:spcPct val="105000"/>
+              </a:lnSpc>
+              <a:spcAft>
+                <a:spcPts val="700"/>
+              </a:spcAft>
+            </a:pPr>
+            <a:r>
+              <a:rPr sz="1100" b="1" i="0" lang="en-AU">
+                <a:solidFill>
+                  <a:srgbClr val="66800B"/>
+                </a:solidFill>
+                <a:latin typeface="IBM Plex Sans"/>
+                <a:cs typeface="IBM Plex Sans"/>
+              </a:rPr>
+              <a:t>▪ </a:t>
+            </a:r>
+            <a:r>
+              <a:rPr sz="1100" b="0" i="0" lang="en-AU">
+                <a:solidFill>
+                  <a:srgbClr val="100F0F"/>
+                </a:solidFill>
+                <a:latin typeface="IBM Plex Sans"/>
+                <a:cs typeface="IBM Plex Sans"/>
+              </a:rPr>
+              <a:t>LRMC: joint capacity + dispatch LP</a:t>
+            </a:r>
+          </a:p>
+          <a:p>
+            <a:pPr>
+              <a:lnSpc>
+                <a:spcPct val="105000"/>
+              </a:lnSpc>
+              <a:spcAft>
+                <a:spcPts val="700"/>
+              </a:spcAft>
+            </a:pPr>
+            <a:r>
+              <a:rPr sz="1100" b="1" i="0" lang="en-AU">
+                <a:solidFill>
+                  <a:srgbClr val="66800B"/>
+                </a:solidFill>
+                <a:latin typeface="IBM Plex Sans"/>
+                <a:cs typeface="IBM Plex Sans"/>
+              </a:rPr>
+              <a:t>▪ </a:t>
+            </a:r>
+            <a:r>
+              <a:rPr sz="1100" b="0" i="0" lang="en-AU">
+                <a:solidFill>
+                  <a:srgbClr val="100F0F"/>
+                </a:solidFill>
+                <a:latin typeface="IBM Plex Sans"/>
+                <a:cs typeface="IBM Plex Sans"/>
+              </a:rPr>
+              <a:t>Anchor years 2035–2050</a:t>
+            </a:r>
+          </a:p>
+          <a:p>
+            <a:pPr>
+              <a:lnSpc>
+                <a:spcPct val="105000"/>
+              </a:lnSpc>
+              <a:spcAft>
+                <a:spcPts val="700"/>
+              </a:spcAft>
+            </a:pPr>
+            <a:r>
+              <a:rPr sz="1100" b="1" i="0" lang="en-AU">
+                <a:solidFill>
+                  <a:srgbClr val="66800B"/>
+                </a:solidFill>
+                <a:latin typeface="IBM Plex Sans"/>
+                <a:cs typeface="IBM Plex Sans"/>
+              </a:rPr>
+              <a:t>▪ </a:t>
+            </a:r>
+            <a:r>
+              <a:rPr sz="1100" b="0" i="0" lang="en-AU">
+                <a:solidFill>
+                  <a:srgbClr val="100F0F"/>
+                </a:solidFill>
+                <a:latin typeface="IBM Plex Sans"/>
+                <a:cs typeface="IBM Plex Sans"/>
+              </a:rPr>
+              <a:t>Least-cost fleet — each technology earns its cost of capital</a:t>
+            </a:r>
+          </a:p>
+          <a:p>
+            <a:pPr>
+              <a:lnSpc>
+                <a:spcPct val="105000"/>
+              </a:lnSpc>
+              <a:spcAft>
+                <a:spcPts val="700"/>
+              </a:spcAft>
+            </a:pPr>
+            <a:r>
+              <a:rPr sz="1100" b="1" i="0" lang="en-AU">
+                <a:solidFill>
+                  <a:srgbClr val="66800B"/>
+                </a:solidFill>
+                <a:latin typeface="IBM Plex Sans"/>
+                <a:cs typeface="IBM Plex Sans"/>
+              </a:rPr>
+              <a:t>▪ </a:t>
+            </a:r>
+            <a:r>
+              <a:rPr sz="1100" b="0" i="0" lang="en-AU">
+                <a:solidFill>
+                  <a:srgbClr val="100F0F"/>
+                </a:solidFill>
+                <a:latin typeface="IBM Plex Sans"/>
+                <a:cs typeface="IBM Plex Sans"/>
+              </a:rPr>
+              <a:t>Capacity path 2025–2050</a:t>
+            </a:r>
+          </a:p>
+        </p:txBody>
+      </p:sp>
+      <p:sp>
+        <p:nvSpPr>
+          <p:cNvPr id="14" name="Right Arrow 13"/>
+          <p:cNvSpPr/>
+          <p:nvPr/>
+        </p:nvSpPr>
+        <p:spPr>
+          <a:xfrm>
+            <a:off x="5952744" y="3017520"/>
+            <a:ext cx="292608" cy="365760"/>
+          </a:xfrm>
+          <a:prstGeom prst="rightArrow">
+            <a:avLst/>
+          </a:prstGeom>
+          <a:solidFill>
+            <a:srgbClr val="B7B5AC"/>
+          </a:solidFill>
+          <a:ln>
+            <a:noFill/>
+          </a:ln>
+          <a:effectLst/>
+        </p:spPr>
+        <p:txBody>
+          <a:bodyPr rtlCol="0" anchor="ctr"/>
+          <a:lstStyle/>
+          <a:p>
+            <a:pPr algn="ctr"/>
+          </a:p>
+        </p:txBody>
+      </p:sp>
+      <p:sp>
+        <p:nvSpPr>
+          <p:cNvPr id="15" name="Rectangle 14"/>
+          <p:cNvSpPr/>
+          <p:nvPr/>
+        </p:nvSpPr>
+        <p:spPr>
+          <a:xfrm>
+            <a:off x="6291072" y="1691640"/>
+            <a:ext cx="2487168" cy="502920"/>
+          </a:xfrm>
+          <a:prstGeom prst="rect">
+            <a:avLst/>
+          </a:prstGeom>
+          <a:solidFill>
+            <a:srgbClr val="24837B"/>
+          </a:solidFill>
+          <a:ln>
+            <a:noFill/>
+          </a:ln>
+          <a:effectLst/>
+        </p:spPr>
+        <p:txBody>
+          <a:bodyPr rtlCol="0" anchor="ctr"/>
+          <a:lstStyle/>
+          <a:p>
+            <a:pPr algn="ctr"/>
+          </a:p>
+        </p:txBody>
+      </p:sp>
+      <p:sp>
+        <p:nvSpPr>
+          <p:cNvPr id="16" name="TextBox 15"/>
+          <p:cNvSpPr txBox="1"/>
+          <p:nvPr/>
+        </p:nvSpPr>
+        <p:spPr>
+          <a:xfrm>
+            <a:off x="6291072" y="1691640"/>
+            <a:ext cx="2487168" cy="502920"/>
+          </a:xfrm>
+          <a:prstGeom prst="rect">
+            <a:avLst/>
+          </a:prstGeom>
+          <a:noFill/>
+        </p:spPr>
+        <p:txBody>
+          <a:bodyPr wrap="none" anchor="ctr" lIns="118872" tIns="0" bIns="0">
+            <a:spAutoFit/>
+          </a:bodyPr>
+          <a:lstStyle/>
+          <a:p>
+            <a:r>
+              <a:rPr sz="1300" b="1" i="0" lang="en-AU">
+                <a:solidFill>
+                  <a:srgbClr val="FFFCF0"/>
+                </a:solidFill>
+                <a:latin typeface="IBM Plex Mono"/>
+                <a:cs typeface="IBM Plex Mono"/>
+              </a:rPr>
+              <a:t>3   </a:t>
+            </a:r>
+            <a:r>
+              <a:rPr sz="1400" b="1" i="0" lang="en-AU">
+                <a:solidFill>
+                  <a:srgbClr val="FFFCF0"/>
+                </a:solidFill>
+                <a:latin typeface="IBM Plex Sans"/>
+                <a:cs typeface="IBM Plex Sans"/>
+              </a:rPr>
+              <a:t>Dispatch LP</a:t>
+            </a:r>
+          </a:p>
+        </p:txBody>
+      </p:sp>
+      <p:sp>
+        <p:nvSpPr>
+          <p:cNvPr id="17" name="Rectangle 16"/>
+          <p:cNvSpPr/>
+          <p:nvPr/>
+        </p:nvSpPr>
+        <p:spPr>
+          <a:xfrm>
+            <a:off x="6291072" y="2194560"/>
+            <a:ext cx="2487168" cy="2514600"/>
+          </a:xfrm>
+          <a:prstGeom prst="rect">
+            <a:avLst/>
+          </a:prstGeom>
+          <a:solidFill>
+            <a:srgbClr val="FFFCF0"/>
+          </a:solidFill>
+          <a:ln w="15875">
+            <a:solidFill>
+              <a:srgbClr val="24837B"/>
+            </a:solidFill>
+          </a:ln>
+          <a:effectLst/>
+        </p:spPr>
+        <p:txBody>
+          <a:bodyPr rtlCol="0" anchor="ctr"/>
+          <a:lstStyle/>
+          <a:p>
+            <a:pPr algn="ctr"/>
+          </a:p>
+        </p:txBody>
+      </p:sp>
+      <p:sp>
+        <p:nvSpPr>
+          <p:cNvPr id="18" name="TextBox 17"/>
+          <p:cNvSpPr txBox="1"/>
+          <p:nvPr/>
+        </p:nvSpPr>
+        <p:spPr>
+          <a:xfrm>
+            <a:off x="6291072" y="2194560"/>
+            <a:ext cx="2487168" cy="2514600"/>
+          </a:xfrm>
+          <a:prstGeom prst="rect">
+            <a:avLst/>
+          </a:prstGeom>
+          <a:noFill/>
+        </p:spPr>
+        <p:txBody>
+          <a:bodyPr wrap="square" anchor="ctr" lIns="118872" tIns="73152">
+            <a:spAutoFit/>
+          </a:bodyPr>
+          <a:lstStyle/>
+          <a:p>
+            <a:pPr>
+              <a:lnSpc>
+                <a:spcPct val="105000"/>
+              </a:lnSpc>
+              <a:spcAft>
+                <a:spcPts val="700"/>
+              </a:spcAft>
+            </a:pPr>
+            <a:r>
+              <a:rPr sz="1100" b="1" i="0" lang="en-AU">
+                <a:solidFill>
+                  <a:srgbClr val="24837B"/>
+                </a:solidFill>
+                <a:latin typeface="IBM Plex Sans"/>
+                <a:cs typeface="IBM Plex Sans"/>
+              </a:rPr>
+              <a:t>▪ </a:t>
+            </a:r>
+            <a:r>
+              <a:rPr sz="1100" b="0" i="0" lang="en-AU">
+                <a:solidFill>
+                  <a:srgbClr val="100F0F"/>
+                </a:solidFill>
+                <a:latin typeface="IBM Plex Sans"/>
+                <a:cs typeface="IBM Plex Sans"/>
+              </a:rPr>
+              <a:t>Supply cleared against demand — every half-hour, each region</a:t>
+            </a:r>
+          </a:p>
+          <a:p>
+            <a:pPr>
+              <a:lnSpc>
+                <a:spcPct val="105000"/>
+              </a:lnSpc>
+              <a:spcAft>
+                <a:spcPts val="700"/>
+              </a:spcAft>
+            </a:pPr>
+            <a:r>
+              <a:rPr sz="1100" b="1" i="0" lang="en-AU">
+                <a:solidFill>
+                  <a:srgbClr val="24837B"/>
+                </a:solidFill>
+                <a:latin typeface="IBM Plex Sans"/>
+                <a:cs typeface="IBM Plex Sans"/>
+              </a:rPr>
+              <a:t>▪ </a:t>
+            </a:r>
+            <a:r>
+              <a:rPr sz="1100" b="0" i="0" lang="en-AU">
+                <a:solidFill>
+                  <a:srgbClr val="100F0F"/>
+                </a:solidFill>
+                <a:latin typeface="IBM Plex Sans"/>
+                <a:cs typeface="IBM Plex Sans"/>
+              </a:rPr>
+              <a:t>17,520 LP solves per year (HiGHS)</a:t>
+            </a:r>
+          </a:p>
+          <a:p>
+            <a:pPr>
+              <a:lnSpc>
+                <a:spcPct val="105000"/>
+              </a:lnSpc>
+              <a:spcAft>
+                <a:spcPts val="700"/>
+              </a:spcAft>
+            </a:pPr>
+            <a:r>
+              <a:rPr sz="1100" b="1" i="0" lang="en-AU">
+                <a:solidFill>
+                  <a:srgbClr val="24837B"/>
+                </a:solidFill>
+                <a:latin typeface="IBM Plex Sans"/>
+                <a:cs typeface="IBM Plex Sans"/>
+              </a:rPr>
+              <a:t>▪ </a:t>
+            </a:r>
+            <a:r>
+              <a:rPr sz="1100" b="0" i="0" lang="en-AU">
+                <a:solidFill>
+                  <a:srgbClr val="100F0F"/>
+                </a:solidFill>
+                <a:latin typeface="IBM Plex Sans"/>
+                <a:cs typeface="IBM Plex Sans"/>
+              </a:rPr>
+              <a:t>Generators · batteries · interconnectors · network limits</a:t>
+            </a:r>
+          </a:p>
+        </p:txBody>
+      </p:sp>
+      <p:sp>
+        <p:nvSpPr>
+          <p:cNvPr id="19" name="Right Arrow 18"/>
+          <p:cNvSpPr/>
+          <p:nvPr/>
+        </p:nvSpPr>
+        <p:spPr>
+          <a:xfrm>
+            <a:off x="8823960" y="3017520"/>
+            <a:ext cx="292608" cy="365760"/>
+          </a:xfrm>
+          <a:prstGeom prst="rightArrow">
+            <a:avLst/>
+          </a:prstGeom>
+          <a:solidFill>
+            <a:srgbClr val="B7B5AC"/>
+          </a:solidFill>
+          <a:ln>
+            <a:noFill/>
+          </a:ln>
+          <a:effectLst/>
+        </p:spPr>
+        <p:txBody>
+          <a:bodyPr rtlCol="0" anchor="ctr"/>
+          <a:lstStyle/>
+          <a:p>
+            <a:pPr algn="ctr"/>
+          </a:p>
+        </p:txBody>
+      </p:sp>
+      <p:sp>
+        <p:nvSpPr>
+          <p:cNvPr id="20" name="Rectangle 19"/>
+          <p:cNvSpPr/>
+          <p:nvPr/>
+        </p:nvSpPr>
+        <p:spPr>
+          <a:xfrm>
+            <a:off x="9162288" y="1691640"/>
+            <a:ext cx="2487168" cy="502920"/>
+          </a:xfrm>
+          <a:prstGeom prst="rect">
+            <a:avLst/>
+          </a:prstGeom>
+          <a:solidFill>
+            <a:srgbClr val="BC5215"/>
+          </a:solidFill>
+          <a:ln>
+            <a:noFill/>
+          </a:ln>
+          <a:effectLst/>
+        </p:spPr>
+        <p:txBody>
+          <a:bodyPr rtlCol="0" anchor="ctr"/>
+          <a:lstStyle/>
+          <a:p>
+            <a:pPr algn="ctr"/>
+          </a:p>
+        </p:txBody>
+      </p:sp>
+      <p:sp>
+        <p:nvSpPr>
+          <p:cNvPr id="21" name="TextBox 20"/>
+          <p:cNvSpPr txBox="1"/>
+          <p:nvPr/>
+        </p:nvSpPr>
+        <p:spPr>
+          <a:xfrm>
+            <a:off x="9162288" y="1691640"/>
+            <a:ext cx="2487168" cy="502920"/>
+          </a:xfrm>
+          <a:prstGeom prst="rect">
+            <a:avLst/>
+          </a:prstGeom>
+          <a:noFill/>
+        </p:spPr>
+        <p:txBody>
+          <a:bodyPr wrap="none" anchor="ctr" lIns="118872" tIns="0" bIns="0">
+            <a:spAutoFit/>
+          </a:bodyPr>
+          <a:lstStyle/>
+          <a:p>
+            <a:r>
+              <a:rPr sz="1300" b="1" i="0" lang="en-AU">
+                <a:solidFill>
+                  <a:srgbClr val="FFFCF0"/>
+                </a:solidFill>
+                <a:latin typeface="IBM Plex Mono"/>
+                <a:cs typeface="IBM Plex Mono"/>
+              </a:rPr>
+              <a:t>4   </a:t>
+            </a:r>
+            <a:r>
+              <a:rPr sz="1400" b="1" i="0" lang="en-AU">
+                <a:solidFill>
+                  <a:srgbClr val="FFFCF0"/>
+                </a:solidFill>
+                <a:latin typeface="IBM Plex Sans"/>
+                <a:cs typeface="IBM Plex Sans"/>
+              </a:rPr>
+              <a:t>Price forecasts</a:t>
+            </a:r>
+          </a:p>
+        </p:txBody>
+      </p:sp>
+      <p:sp>
+        <p:nvSpPr>
+          <p:cNvPr id="22" name="Rectangle 21"/>
+          <p:cNvSpPr/>
+          <p:nvPr/>
+        </p:nvSpPr>
+        <p:spPr>
+          <a:xfrm>
+            <a:off x="9162288" y="2194560"/>
+            <a:ext cx="2487168" cy="2514600"/>
+          </a:xfrm>
+          <a:prstGeom prst="rect">
+            <a:avLst/>
+          </a:prstGeom>
+          <a:solidFill>
+            <a:srgbClr val="FFFCF0"/>
+          </a:solidFill>
+          <a:ln w="15875">
+            <a:solidFill>
+              <a:srgbClr val="BC5215"/>
+            </a:solidFill>
+          </a:ln>
+          <a:effectLst/>
+        </p:spPr>
+        <p:txBody>
+          <a:bodyPr rtlCol="0" anchor="ctr"/>
+          <a:lstStyle/>
+          <a:p>
+            <a:pPr algn="ctr"/>
+          </a:p>
+        </p:txBody>
+      </p:sp>
+      <p:sp>
+        <p:nvSpPr>
+          <p:cNvPr id="23" name="TextBox 22"/>
+          <p:cNvSpPr txBox="1"/>
+          <p:nvPr/>
+        </p:nvSpPr>
+        <p:spPr>
+          <a:xfrm>
+            <a:off x="9162288" y="2194560"/>
+            <a:ext cx="2487168" cy="2514600"/>
+          </a:xfrm>
+          <a:prstGeom prst="rect">
+            <a:avLst/>
+          </a:prstGeom>
+          <a:noFill/>
+        </p:spPr>
+        <p:txBody>
+          <a:bodyPr wrap="square" anchor="ctr" lIns="118872" tIns="73152">
+            <a:spAutoFit/>
+          </a:bodyPr>
+          <a:lstStyle/>
+          <a:p>
+            <a:pPr>
+              <a:lnSpc>
+                <a:spcPct val="105000"/>
+              </a:lnSpc>
+              <a:spcAft>
+                <a:spcPts val="700"/>
+              </a:spcAft>
+            </a:pPr>
+            <a:r>
+              <a:rPr sz="1100" b="1" i="0" lang="en-AU">
+                <a:solidFill>
+                  <a:srgbClr val="BC5215"/>
+                </a:solidFill>
+                <a:latin typeface="IBM Plex Sans"/>
+                <a:cs typeface="IBM Plex Sans"/>
+              </a:rPr>
+              <a:t>▪ </a:t>
+            </a:r>
+            <a:r>
+              <a:rPr sz="1100" b="0" i="0" lang="en-AU">
+                <a:solidFill>
+                  <a:srgbClr val="100F0F"/>
+                </a:solidFill>
+                <a:latin typeface="IBM Plex Sans"/>
+                <a:cs typeface="IBM Plex Sans"/>
+              </a:rPr>
+              <a:t>Half-hourly regional spot prices to 2050</a:t>
+            </a:r>
+          </a:p>
+          <a:p>
+            <a:pPr>
+              <a:lnSpc>
+                <a:spcPct val="105000"/>
+              </a:lnSpc>
+              <a:spcAft>
+                <a:spcPts val="700"/>
+              </a:spcAft>
+            </a:pPr>
+            <a:r>
+              <a:rPr sz="1100" b="1" i="0" lang="en-AU">
+                <a:solidFill>
+                  <a:srgbClr val="BC5215"/>
+                </a:solidFill>
+                <a:latin typeface="IBM Plex Sans"/>
+                <a:cs typeface="IBM Plex Sans"/>
+              </a:rPr>
+              <a:t>▪ </a:t>
+            </a:r>
+            <a:r>
+              <a:rPr sz="1100" b="0" i="0" lang="en-AU">
+                <a:solidFill>
+                  <a:srgbClr val="100F0F"/>
+                </a:solidFill>
+                <a:latin typeface="IBM Plex Sans"/>
+                <a:cs typeface="IBM Plex Sans"/>
+              </a:rPr>
+              <a:t>Generation mix · emissions · project ROIs</a:t>
+            </a:r>
+          </a:p>
+          <a:p>
+            <a:pPr>
+              <a:lnSpc>
+                <a:spcPct val="105000"/>
+              </a:lnSpc>
+              <a:spcAft>
+                <a:spcPts val="700"/>
+              </a:spcAft>
+            </a:pPr>
+            <a:r>
+              <a:rPr sz="1100" b="1" i="0" lang="en-AU">
+                <a:solidFill>
+                  <a:srgbClr val="BC5215"/>
+                </a:solidFill>
+                <a:latin typeface="IBM Plex Sans"/>
+                <a:cs typeface="IBM Plex Sans"/>
+              </a:rPr>
+              <a:t>▪ </a:t>
+            </a:r>
+            <a:r>
+              <a:rPr sz="1100" b="0" i="0" lang="en-AU">
+                <a:solidFill>
+                  <a:srgbClr val="100F0F"/>
+                </a:solidFill>
+                <a:latin typeface="IBM Plex Sans"/>
+                <a:cs typeface="IBM Plex Sans"/>
+              </a:rPr>
+              <a:t>Probabilistic over weather years → dashboard</a:t>
+            </a:r>
+          </a:p>
+        </p:txBody>
+      </p:sp>
+      <p:sp>
+        <p:nvSpPr>
+          <p:cNvPr id="24" name="Rectangle 23"/>
+          <p:cNvSpPr/>
+          <p:nvPr/>
+        </p:nvSpPr>
+        <p:spPr>
+          <a:xfrm>
+            <a:off x="548640" y="5074920"/>
+            <a:ext cx="11100816" cy="841248"/>
+          </a:xfrm>
+          <a:prstGeom prst="rect">
+            <a:avLst/>
+          </a:prstGeom>
+          <a:solidFill>
+            <a:srgbClr val="F2F0E5"/>
+          </a:solidFill>
+          <a:ln>
+            <a:noFill/>
+          </a:ln>
+          <a:effectLst/>
+        </p:spPr>
+        <p:txBody>
+          <a:bodyPr rtlCol="0" anchor="ctr"/>
+          <a:lstStyle/>
+          <a:p>
+            <a:pPr algn="ctr"/>
+          </a:p>
+        </p:txBody>
+      </p:sp>
+      <p:sp>
+        <p:nvSpPr>
+          <p:cNvPr id="25" name="Rectangle 24"/>
+          <p:cNvSpPr/>
+          <p:nvPr/>
+        </p:nvSpPr>
+        <p:spPr>
+          <a:xfrm>
+            <a:off x="548640" y="5074920"/>
+            <a:ext cx="82296" cy="841248"/>
+          </a:xfrm>
+          <a:prstGeom prst="rect">
+            <a:avLst/>
+          </a:prstGeom>
+          <a:solidFill>
+            <a:srgbClr val="24837B"/>
+          </a:solidFill>
+          <a:ln>
+            <a:noFill/>
+          </a:ln>
+          <a:effectLst/>
+        </p:spPr>
+        <p:txBody>
+          <a:bodyPr rtlCol="0" anchor="ctr"/>
+          <a:lstStyle/>
+          <a:p>
+            <a:pPr algn="ctr"/>
+          </a:p>
+        </p:txBody>
+      </p:sp>
+      <p:sp>
+        <p:nvSpPr>
+          <p:cNvPr id="26" name="TextBox 25"/>
+          <p:cNvSpPr txBox="1"/>
+          <p:nvPr/>
+        </p:nvSpPr>
+        <p:spPr>
+          <a:xfrm>
+            <a:off x="804672" y="5074920"/>
+            <a:ext cx="10643616" cy="841248"/>
+          </a:xfrm>
+          <a:prstGeom prst="rect">
+            <a:avLst/>
+          </a:prstGeom>
+          <a:noFill/>
+        </p:spPr>
+        <p:txBody>
+          <a:bodyPr wrap="square" anchor="ctr" tIns="0" bIns="0">
+            <a:spAutoFit/>
+          </a:bodyPr>
+          <a:lstStyle/>
+          <a:p>
+            <a:r>
+              <a:rPr sz="1500" b="0" i="0" lang="en-AU">
+                <a:solidFill>
+                  <a:srgbClr val="100F0F"/>
+                </a:solidFill>
+                <a:latin typeface="IBM Plex Sans"/>
+                <a:cs typeface="IBM Plex Sans"/>
+              </a:rPr>
+              <a:t>Spot prices emerge as the </a:t>
+            </a:r>
+            <a:r>
+              <a:rPr sz="1500" b="1" i="0" lang="en-AU">
+                <a:solidFill>
+                  <a:srgbClr val="24837B"/>
+                </a:solidFill>
+                <a:latin typeface="IBM Plex Sans"/>
+                <a:cs typeface="IBM Plex Sans"/>
+              </a:rPr>
+              <a:t>dual (shadow) prices</a:t>
+            </a:r>
+            <a:r>
+              <a:rPr sz="1500" b="0" i="0" lang="en-AU">
+                <a:solidFill>
+                  <a:srgbClr val="100F0F"/>
+                </a:solidFill>
+                <a:latin typeface="IBM Plex Sans"/>
+                <a:cs typeface="IBM Plex Sans"/>
+              </a:rPr>
+              <a:t> of each region's supply = demand balance — the same price-formation mechanism as </a:t>
+            </a:r>
+            <a:r>
+              <a:rPr sz="1500" b="1" i="0" lang="en-AU">
+                <a:solidFill>
+                  <a:srgbClr val="24837B"/>
+                </a:solidFill>
+                <a:latin typeface="IBM Plex Sans"/>
+                <a:cs typeface="IBM Plex Sans"/>
+              </a:rPr>
+              <a:t>AEMO's NEMDE.</a:t>
+            </a:r>
+          </a:p>
+        </p:txBody>
+      </p:sp>
+      <p:sp>
+        <p:nvSpPr>
+          <p:cNvPr id="27" name="Rectangle 26"/>
+          <p:cNvSpPr/>
+          <p:nvPr/>
+        </p:nvSpPr>
+        <p:spPr>
+          <a:xfrm>
+            <a:off x="0" y="6419088"/>
+            <a:ext cx="12191695" cy="25400"/>
+          </a:xfrm>
+          <a:prstGeom prst="rect">
+            <a:avLst/>
+          </a:prstGeom>
+          <a:solidFill>
+            <a:srgbClr val="24837B"/>
+          </a:solidFill>
+          <a:ln>
+            <a:noFill/>
+          </a:ln>
+          <a:effectLst/>
+        </p:spPr>
+        <p:txBody>
+          <a:bodyPr rtlCol="0" anchor="ctr"/>
+          <a:lstStyle/>
+          <a:p>
+            <a:pPr algn="ctr"/>
+          </a:p>
+        </p:txBody>
+      </p:sp>
+      <p:sp>
+        <p:nvSpPr>
+          <p:cNvPr id="28" name="TextBox 27"/>
+          <p:cNvSpPr txBox="1"/>
+          <p:nvPr/>
+        </p:nvSpPr>
+        <p:spPr>
+          <a:xfrm>
+            <a:off x="502920" y="6473952"/>
+            <a:ext cx="7315200" cy="320040"/>
+          </a:xfrm>
+          <a:prstGeom prst="rect">
+            <a:avLst/>
+          </a:prstGeom>
+          <a:noFill/>
+        </p:spPr>
+        <p:txBody>
+          <a:bodyPr wrap="square" anchor="ctr" lIns="0" rIns="0" tIns="0" bIns="0">
+            <a:spAutoFit/>
+          </a:bodyPr>
+          <a:lstStyle/>
+          <a:p>
+            <a:pPr algn="l"/>
+            <a:r>
+              <a:rPr sz="900" b="0" i="0" lang="en-AU">
+                <a:solidFill>
+                  <a:srgbClr val="6F6E69"/>
+                </a:solidFill>
+                <a:latin typeface="IBM Plex Mono"/>
+                <a:cs typeface="IBM Plex Mono"/>
+              </a:rPr>
+              <a:t>ITK Services  ·  david.leitch@itkservices.com.au</a:t>
+            </a:r>
+          </a:p>
+        </p:txBody>
+      </p:sp>
+      <p:sp>
+        <p:nvSpPr>
+          <p:cNvPr id="29" name="TextBox 28"/>
+          <p:cNvSpPr txBox="1"/>
+          <p:nvPr/>
+        </p:nvSpPr>
+        <p:spPr>
+          <a:xfrm>
+            <a:off x="8229600" y="6473952"/>
+            <a:ext cx="3456432" cy="320040"/>
+          </a:xfrm>
+          <a:prstGeom prst="rect">
+            <a:avLst/>
+          </a:prstGeom>
+          <a:noFill/>
+        </p:spPr>
+        <p:txBody>
+          <a:bodyPr wrap="square" anchor="ctr" lIns="0" rIns="0" tIns="0" bIns="0">
+            <a:spAutoFit/>
+          </a:bodyPr>
+          <a:lstStyle/>
+          <a:p>
+            <a:pPr algn="r"/>
+            <a:r>
+              <a:rPr sz="1000" b="1" i="0" lang="en-AU" spc="200">
+                <a:solidFill>
+                  <a:srgbClr val="24837B"/>
+                </a:solidFill>
+                <a:latin typeface="IBM Plex Sans"/>
+                <a:cs typeface="IBM Plex Sans"/>
+              </a:rPr>
+              <a:t>ITK</a:t>
+            </a:r>
+          </a:p>
+        </p:txBody>
+      </p:sp>
+    </p:spTree>
+  </p:cSld>
+  <p:clrMapOvr>
+    <a:masterClrMapping/>
+  </p:clrMapOvr>
+</p:sld>
+</file>
+
+<file path=ppt/slides/slide6.xml><?xml version="1.0" encoding="utf-8"?>
+<p:sld xmlns:a="http://schemas.openxmlformats.org/drawingml/2006/main" xmlns:p="http://schemas.openxmlformats.org/presentationml/2006/main" xmlns:r="http://schemas.openxmlformats.org/officeDocument/2006/relationships">
+  <p:cSld>
+    <p:bg>
+      <p:bgPr>
+        <a:solidFill>
+          <a:srgbClr val="FFFCF0"/>
+        </a:solidFill>
+        <a:effectLst/>
+      </p:bgPr>
+    </p:bg>
+    <p:spTree>
+      <p:nvGrpSpPr>
+        <p:cNvPr id="1" name=""/>
+        <p:cNvGrpSpPr/>
+        <p:nvPr/>
+      </p:nvGrpSpPr>
+      <p:grpSpPr/>
+      <p:sp>
+        <p:nvSpPr>
+          <p:cNvPr id="2" name="Rectangle 1"/>
+          <p:cNvSpPr/>
+          <p:nvPr/>
+        </p:nvSpPr>
+        <p:spPr>
+          <a:xfrm>
+            <a:off x="0" y="0"/>
+            <a:ext cx="320040" cy="6858000"/>
+          </a:xfrm>
+          <a:prstGeom prst="rect">
+            <a:avLst/>
+          </a:prstGeom>
+          <a:solidFill>
+            <a:srgbClr val="24837B"/>
+          </a:solidFill>
+          <a:ln>
+            <a:noFill/>
+          </a:ln>
+          <a:effectLst/>
+        </p:spPr>
+        <p:txBody>
+          <a:bodyPr rtlCol="0" anchor="ctr"/>
+          <a:lstStyle/>
+          <a:p>
+            <a:pPr algn="ctr"/>
+          </a:p>
+        </p:txBody>
+      </p:sp>
+      <p:sp>
+        <p:nvSpPr>
+          <p:cNvPr id="3" name="TextBox 2"/>
+          <p:cNvSpPr txBox="1"/>
+          <p:nvPr/>
+        </p:nvSpPr>
+        <p:spPr>
+          <a:xfrm>
+            <a:off x="822960" y="2103120"/>
+            <a:ext cx="10058400" cy="914400"/>
+          </a:xfrm>
+          <a:prstGeom prst="rect">
+            <a:avLst/>
+          </a:prstGeom>
+          <a:noFill/>
+        </p:spPr>
+        <p:txBody>
+          <a:bodyPr wrap="square" anchor="t" lIns="0" rIns="0" tIns="0" bIns="0">
+            <a:spAutoFit/>
+          </a:bodyPr>
+          <a:lstStyle/>
+          <a:p>
+            <a:pPr algn="l"/>
+            <a:r>
+              <a:rPr sz="5400" b="1" i="0" lang="en-AU">
+                <a:solidFill>
+                  <a:srgbClr val="100F0F"/>
+                </a:solidFill>
+                <a:latin typeface="IBM Plex Sans"/>
+                <a:cs typeface="IBM Plex Sans"/>
+              </a:rPr>
+              <a:t>Let's talk</a:t>
+            </a:r>
+          </a:p>
+        </p:txBody>
+      </p:sp>
+      <p:sp>
+        <p:nvSpPr>
+          <p:cNvPr id="4" name="Rectangle 3"/>
+          <p:cNvSpPr/>
+          <p:nvPr/>
+        </p:nvSpPr>
+        <p:spPr>
+          <a:xfrm>
+            <a:off x="914400" y="3154680"/>
+            <a:ext cx="2194560" cy="50800"/>
+          </a:xfrm>
+          <a:prstGeom prst="rect">
+            <a:avLst/>
+          </a:prstGeom>
+          <a:solidFill>
+            <a:srgbClr val="24837B"/>
+          </a:solidFill>
+          <a:ln>
+            <a:noFill/>
+          </a:ln>
+          <a:effectLst/>
+        </p:spPr>
+        <p:txBody>
+          <a:bodyPr rtlCol="0" anchor="ctr"/>
+          <a:lstStyle/>
+          <a:p>
+            <a:pPr algn="ctr"/>
+          </a:p>
+        </p:txBody>
+      </p:sp>
+      <p:sp>
+        <p:nvSpPr>
+          <p:cNvPr id="5" name="TextBox 4"/>
+          <p:cNvSpPr txBox="1"/>
+          <p:nvPr/>
+        </p:nvSpPr>
+        <p:spPr>
+          <a:xfrm>
+            <a:off x="914400" y="3520440"/>
+            <a:ext cx="9144000" cy="457200"/>
+          </a:xfrm>
+          <a:prstGeom prst="rect">
+            <a:avLst/>
+          </a:prstGeom>
+          <a:noFill/>
+        </p:spPr>
+        <p:txBody>
+          <a:bodyPr wrap="square" anchor="t" lIns="0" rIns="0" tIns="0" bIns="0">
+            <a:spAutoFit/>
+          </a:bodyPr>
+          <a:lstStyle/>
+          <a:p>
+            <a:pPr algn="l"/>
+            <a:r>
+              <a:rPr sz="2200" b="1" i="0" lang="en-AU">
+                <a:solidFill>
+                  <a:srgbClr val="100F0F"/>
+                </a:solidFill>
+                <a:latin typeface="IBM Plex Sans"/>
+                <a:cs typeface="IBM Plex Sans"/>
+              </a:rPr>
+              <a:t>David Leitch</a:t>
+            </a:r>
+          </a:p>
+        </p:txBody>
+      </p:sp>
+      <p:sp>
+        <p:nvSpPr>
+          <p:cNvPr id="6" name="TextBox 5"/>
+          <p:cNvSpPr txBox="1"/>
+          <p:nvPr/>
+        </p:nvSpPr>
+        <p:spPr>
+          <a:xfrm>
+            <a:off x="914400" y="3995928"/>
+            <a:ext cx="9144000" cy="457200"/>
+          </a:xfrm>
+          <a:prstGeom prst="rect">
+            <a:avLst/>
+          </a:prstGeom>
+          <a:noFill/>
+        </p:spPr>
+        <p:txBody>
+          <a:bodyPr wrap="square" anchor="t" lIns="0" rIns="0" tIns="0" bIns="0">
+            <a:spAutoFit/>
+          </a:bodyPr>
+          <a:lstStyle/>
+          <a:p>
+            <a:pPr algn="l"/>
+            <a:r>
+              <a:rPr sz="1800" b="0" i="0" lang="en-AU">
+                <a:solidFill>
+                  <a:srgbClr val="575653"/>
+                </a:solidFill>
+                <a:latin typeface="IBM Plex Sans"/>
+                <a:cs typeface="IBM Plex Sans"/>
+              </a:rPr>
+              <a:t>ITK Services</a:t>
+            </a:r>
+          </a:p>
+        </p:txBody>
+      </p:sp>
+      <p:sp>
+        <p:nvSpPr>
+          <p:cNvPr id="7" name="TextBox 6"/>
+          <p:cNvSpPr txBox="1"/>
+          <p:nvPr/>
+        </p:nvSpPr>
+        <p:spPr>
+          <a:xfrm>
+            <a:off x="914400" y="4471416"/>
+            <a:ext cx="9144000" cy="457200"/>
+          </a:xfrm>
+          <a:prstGeom prst="rect">
+            <a:avLst/>
+          </a:prstGeom>
+          <a:noFill/>
+        </p:spPr>
+        <p:txBody>
+          <a:bodyPr wrap="square" anchor="t" lIns="0" rIns="0" tIns="0" bIns="0">
+            <a:spAutoFit/>
+          </a:bodyPr>
+          <a:lstStyle/>
+          <a:p>
+            <a:pPr algn="l"/>
+            <a:r>
+              <a:rPr sz="1800" b="0" i="0" lang="en-AU">
+                <a:solidFill>
+                  <a:srgbClr val="24837B"/>
+                </a:solidFill>
+                <a:latin typeface="IBM Plex Mono"/>
+                <a:cs typeface="IBM Plex Mono"/>
+              </a:rPr>
+              <a:t>david.leitch@itkservices.com.au</a:t>
+            </a:r>
+          </a:p>
+        </p:txBody>
+      </p:sp>
+      <p:sp>
+        <p:nvSpPr>
+          <p:cNvPr id="8" name="Rectangle 7"/>
+          <p:cNvSpPr/>
+          <p:nvPr/>
+        </p:nvSpPr>
+        <p:spPr>
+          <a:xfrm>
+            <a:off x="0" y="6419088"/>
+            <a:ext cx="12191695" cy="25400"/>
+          </a:xfrm>
+          <a:prstGeom prst="rect">
+            <a:avLst/>
+          </a:prstGeom>
+          <a:solidFill>
+            <a:srgbClr val="24837B"/>
+          </a:solidFill>
+          <a:ln>
+            <a:noFill/>
+          </a:ln>
+          <a:effectLst/>
+        </p:spPr>
         <p:txBody>
           <a:bodyPr rtlCol="0" anchor="ctr"/>
           <a:lstStyle/>

</xml_diff>